<commit_message>
Add a references slide to both decks
New final slide: References (slide 9 of the short deck, 21 of the full one).

Three blocks. The five literature entries are lifted verbatim from the
literature slide of the supplied source PDF — titles, venues and DOIs
unchanged, nothing added. The primary sources are the five manufacturer
datasheets actually filed under cell datasheet/, each labelled with the role it
plays in the threshold matrix. The method citations are the canonical papers
for XGBoost, Isolation Forest, positional encoding and scikit-learn, given in
author/venue/year form without DOIs rather than risk an unverified link, plus
the library versions the benchmark ran against.

Co-Authored-By: Claude Opus 5 <noreply@anthropic.com>
Claude-Session: https://claude.ai/code/session_0133wKuiAxodCssuc16rPzq6
</commit_message>
<xml_diff>
--- a/AI_PBMS_8Slide.pptx
+++ b/AI_PBMS_8Slide.pptx
@@ -13,6 +13,7 @@
     <p:sldId id="261" r:id="rId13"/>
     <p:sldId id="262" r:id="rId14"/>
     <p:sldId id="263" r:id="rId15"/>
+    <p:sldId id="264" r:id="rId16"/>
   </p:sldIdLst>
   <p:sldSz cx="12191695" cy="6858000" type="screen4x3"/>
   <p:notesSz cx="6858000" cy="9144000"/>
@@ -1285,6 +1286,116 @@
           <a:p>
             <a:r>
               <a:t>health. Thank you — happy to take questions.</a:t>
+            </a:r>
+          </a:p>
+        </p:txBody>
+      </p:sp>
+      <p:sp>
+        <p:nvSpPr>
+          <p:cNvPr id="4" name="Slide Number Placeholder 3"/>
+          <p:cNvSpPr>
+            <a:spLocks noGrp="1"/>
+          </p:cNvSpPr>
+          <p:nvPr>
+            <p:ph type="sldNum" idx="5" sz="quarter"/>
+          </p:nvPr>
+        </p:nvSpPr>
+        <p:spPr/>
+      </p:sp>
+    </p:spTree>
+  </p:cSld>
+  <p:clrMapOvr>
+    <a:masterClrMapping/>
+  </p:clrMapOvr>
+</p:notes>
+</file>
+
+<file path=ppt/notesSlides/notesSlide9.xml><?xml version="1.0" encoding="utf-8"?>
+<p:notes xmlns:a="http://schemas.openxmlformats.org/drawingml/2006/main" xmlns:p="http://schemas.openxmlformats.org/presentationml/2006/main" xmlns:r="http://schemas.openxmlformats.org/officeDocument/2006/relationships">
+  <p:cSld>
+    <p:spTree>
+      <p:nvGrpSpPr>
+        <p:cNvPr id="1" name=""/>
+        <p:cNvGrpSpPr/>
+        <p:nvPr/>
+      </p:nvGrpSpPr>
+      <p:grpSpPr>
+        <a:xfrm>
+          <a:off x="0" y="0"/>
+          <a:ext cx="0" cy="0"/>
+          <a:chOff x="0" y="0"/>
+          <a:chExt cx="0" cy="0"/>
+        </a:xfrm>
+      </p:grpSpPr>
+      <p:sp>
+        <p:nvSpPr>
+          <p:cNvPr id="2" name="Slide Image Placeholder 1"/>
+          <p:cNvSpPr>
+            <a:spLocks noGrp="1"/>
+          </p:cNvSpPr>
+          <p:nvPr>
+            <p:ph type="sldImg" idx="2"/>
+          </p:nvPr>
+        </p:nvSpPr>
+        <p:spPr/>
+      </p:sp>
+      <p:sp>
+        <p:nvSpPr>
+          <p:cNvPr id="3" name="Notes Placeholder 2"/>
+          <p:cNvSpPr>
+            <a:spLocks noGrp="1"/>
+          </p:cNvSpPr>
+          <p:nvPr>
+            <p:ph type="body" idx="3" sz="quarter"/>
+          </p:nvPr>
+        </p:nvSpPr>
+        <p:spPr/>
+        <p:txBody>
+          <a:bodyPr/>
+          <a:lstStyle/>
+          <a:p>
+            <a:r>
+              <a:t>Five papers shaped the approach. The first four are the state-of-the-art we</a:t>
+            </a:r>
+          </a:p>
+          <a:p>
+            <a:r>
+              <a:t>benchmarked our thinking against for state-of-charge and remaining-useful-life</a:t>
+            </a:r>
+          </a:p>
+          <a:p>
+            <a:r>
+              <a:t>prediction — bimodal image encoding, single-cycle charging features, multidomain</a:t>
+            </a:r>
+          </a:p>
+          <a:p>
+            <a:r>
+              <a:t>features with CatBoost, and the CNN-BiLSTM-BiGRU attention stack. The fifth,</a:t>
+            </a:r>
+          </a:p>
+          <a:p>
+            <a:r>
+              <a:t>Yang, Xu and Peng in Electronics, is where our confidence-scoring and fault</a:t>
+            </a:r>
+          </a:p>
+          <a:p>
+            <a:r>
+              <a:t>grading framework comes from — that is the source of the three-tier abstain,</a:t>
+            </a:r>
+          </a:p>
+          <a:p>
+            <a:r>
+              <a:t>warn, alert structure on slide five. On the right are the primary sources: the</a:t>
+            </a:r>
+          </a:p>
+          <a:p>
+            <a:r>
+              <a:t>manufacturer datasheets the threshold matrix is parsed from, and the JBD</a:t>
+            </a:r>
+          </a:p>
+          <a:p>
+            <a:r>
+              <a:t>protocol spec the logger was written against. Happy to take questions.</a:t>
             </a:r>
           </a:p>
         </p:txBody>
@@ -14275,6 +14386,2358 @@
                 <a:latin typeface="Inter"/>
               </a:rPr>
               <a:t>Why LFP needs a remap, not an offset</a:t>
+            </a:r>
+          </a:p>
+        </p:txBody>
+      </p:sp>
+    </p:spTree>
+  </p:cSld>
+  <p:clrMapOvr>
+    <a:masterClrMapping/>
+  </p:clrMapOvr>
+</p:sld>
+</file>
+
+<file path=ppt/slides/slide9.xml><?xml version="1.0" encoding="utf-8"?>
+<p:sld xmlns:a="http://schemas.openxmlformats.org/drawingml/2006/main" xmlns:p="http://schemas.openxmlformats.org/presentationml/2006/main" xmlns:r="http://schemas.openxmlformats.org/officeDocument/2006/relationships">
+  <p:cSld>
+    <p:bg>
+      <p:bgPr>
+        <a:solidFill>
+          <a:srgbClr val="FFFFFF"/>
+        </a:solidFill>
+        <a:effectLst/>
+      </p:bgPr>
+    </p:bg>
+    <p:spTree>
+      <p:nvGrpSpPr>
+        <p:cNvPr id="1" name=""/>
+        <p:cNvGrpSpPr/>
+        <p:nvPr/>
+      </p:nvGrpSpPr>
+      <p:grpSpPr/>
+      <p:sp>
+        <p:nvSpPr>
+          <p:cNvPr id="2" name="TextBox 1"/>
+          <p:cNvSpPr txBox="1"/>
+          <p:nvPr/>
+        </p:nvSpPr>
+        <p:spPr>
+          <a:xfrm>
+            <a:off x="566928" y="365760"/>
+            <a:ext cx="11057839" cy="713232"/>
+          </a:xfrm>
+          <a:prstGeom prst="rect">
+            <a:avLst/>
+          </a:prstGeom>
+          <a:noFill/>
+        </p:spPr>
+        <p:txBody>
+          <a:bodyPr wrap="square" anchor="t" lIns="0" rIns="0" tIns="0" bIns="0">
+            <a:spAutoFit/>
+          </a:bodyPr>
+          <a:lstStyle/>
+          <a:p>
+            <a:pPr algn="l">
+              <a:lnSpc>
+                <a:spcPct val="102000"/>
+              </a:lnSpc>
+              <a:spcAft>
+                <a:spcPts val="0"/>
+              </a:spcAft>
+            </a:pPr>
+            <a:r>
+              <a:rPr sz="3300" b="1">
+                <a:solidFill>
+                  <a:srgbClr val="0F172A"/>
+                </a:solidFill>
+                <a:latin typeface="Inter"/>
+              </a:rPr>
+              <a:t>References</a:t>
+            </a:r>
+          </a:p>
+        </p:txBody>
+      </p:sp>
+      <p:sp>
+        <p:nvSpPr>
+          <p:cNvPr id="3" name="Rectangle 2"/>
+          <p:cNvSpPr/>
+          <p:nvPr/>
+        </p:nvSpPr>
+        <p:spPr>
+          <a:xfrm>
+            <a:off x="566928" y="1152144"/>
+            <a:ext cx="1965960" cy="32004"/>
+          </a:xfrm>
+          <a:prstGeom prst="rect">
+            <a:avLst/>
+          </a:prstGeom>
+          <a:solidFill>
+            <a:srgbClr val="0E7490"/>
+          </a:solidFill>
+          <a:ln>
+            <a:noFill/>
+          </a:ln>
+          <a:effectLst/>
+        </p:spPr>
+        <p:style>
+          <a:lnRef idx="1">
+            <a:schemeClr val="accent1"/>
+          </a:lnRef>
+          <a:fillRef idx="3">
+            <a:schemeClr val="accent1"/>
+          </a:fillRef>
+          <a:effectRef idx="2">
+            <a:schemeClr val="accent1"/>
+          </a:effectRef>
+          <a:fontRef idx="minor">
+            <a:schemeClr val="lt1"/>
+          </a:fontRef>
+        </p:style>
+        <p:txBody>
+          <a:bodyPr rtlCol="0" anchor="ctr"/>
+          <a:lstStyle/>
+          <a:p/>
+        </p:txBody>
+      </p:sp>
+      <p:sp>
+        <p:nvSpPr>
+          <p:cNvPr id="4" name="Rectangle 3"/>
+          <p:cNvSpPr/>
+          <p:nvPr/>
+        </p:nvSpPr>
+        <p:spPr>
+          <a:xfrm>
+            <a:off x="2532888" y="1152144"/>
+            <a:ext cx="9091879" cy="32004"/>
+          </a:xfrm>
+          <a:prstGeom prst="rect">
+            <a:avLst/>
+          </a:prstGeom>
+          <a:solidFill>
+            <a:srgbClr val="CBD5E1"/>
+          </a:solidFill>
+          <a:ln>
+            <a:noFill/>
+          </a:ln>
+          <a:effectLst/>
+        </p:spPr>
+        <p:style>
+          <a:lnRef idx="1">
+            <a:schemeClr val="accent1"/>
+          </a:lnRef>
+          <a:fillRef idx="3">
+            <a:schemeClr val="accent1"/>
+          </a:fillRef>
+          <a:effectRef idx="2">
+            <a:schemeClr val="accent1"/>
+          </a:effectRef>
+          <a:fontRef idx="minor">
+            <a:schemeClr val="lt1"/>
+          </a:fontRef>
+        </p:style>
+        <p:txBody>
+          <a:bodyPr rtlCol="0" anchor="ctr"/>
+          <a:lstStyle/>
+          <a:p/>
+        </p:txBody>
+      </p:sp>
+      <p:sp>
+        <p:nvSpPr>
+          <p:cNvPr id="5" name="TextBox 4"/>
+          <p:cNvSpPr txBox="1"/>
+          <p:nvPr/>
+        </p:nvSpPr>
+        <p:spPr>
+          <a:xfrm>
+            <a:off x="566928" y="6400800"/>
+            <a:ext cx="4572000" cy="237744"/>
+          </a:xfrm>
+          <a:prstGeom prst="rect">
+            <a:avLst/>
+          </a:prstGeom>
+          <a:noFill/>
+        </p:spPr>
+        <p:txBody>
+          <a:bodyPr wrap="square" anchor="t" lIns="0" rIns="0" tIns="0" bIns="0">
+            <a:spAutoFit/>
+          </a:bodyPr>
+          <a:lstStyle/>
+          <a:p>
+            <a:pPr algn="l">
+              <a:lnSpc>
+                <a:spcPct val="118000"/>
+              </a:lnSpc>
+              <a:spcAft>
+                <a:spcPts val="0"/>
+              </a:spcAft>
+            </a:pPr>
+            <a:r>
+              <a:rPr sz="950" b="0">
+                <a:solidFill>
+                  <a:srgbClr val="475569"/>
+                </a:solidFill>
+                <a:latin typeface="Inter"/>
+              </a:rPr>
+              <a:t>AI-PBMS  ·  Team ANS_4X</a:t>
+            </a:r>
+          </a:p>
+        </p:txBody>
+      </p:sp>
+      <p:sp>
+        <p:nvSpPr>
+          <p:cNvPr id="6" name="TextBox 5"/>
+          <p:cNvSpPr txBox="1"/>
+          <p:nvPr/>
+        </p:nvSpPr>
+        <p:spPr>
+          <a:xfrm>
+            <a:off x="10527487" y="6400800"/>
+            <a:ext cx="1097280" cy="237744"/>
+          </a:xfrm>
+          <a:prstGeom prst="rect">
+            <a:avLst/>
+          </a:prstGeom>
+          <a:noFill/>
+        </p:spPr>
+        <p:txBody>
+          <a:bodyPr wrap="square" anchor="t" lIns="0" rIns="0" tIns="0" bIns="0">
+            <a:spAutoFit/>
+          </a:bodyPr>
+          <a:lstStyle/>
+          <a:p>
+            <a:pPr algn="r">
+              <a:lnSpc>
+                <a:spcPct val="118000"/>
+              </a:lnSpc>
+              <a:spcAft>
+                <a:spcPts val="0"/>
+              </a:spcAft>
+            </a:pPr>
+            <a:r>
+              <a:rPr sz="1050" b="0">
+                <a:solidFill>
+                  <a:srgbClr val="475569"/>
+                </a:solidFill>
+                <a:latin typeface="Inter"/>
+              </a:rPr>
+              <a:t>9</a:t>
+            </a:r>
+          </a:p>
+        </p:txBody>
+      </p:sp>
+      <p:sp>
+        <p:nvSpPr>
+          <p:cNvPr id="7" name="TextBox 6"/>
+          <p:cNvSpPr txBox="1"/>
+          <p:nvPr/>
+        </p:nvSpPr>
+        <p:spPr>
+          <a:xfrm>
+            <a:off x="566928" y="1444752"/>
+            <a:ext cx="5797296" cy="219456"/>
+          </a:xfrm>
+          <a:prstGeom prst="rect">
+            <a:avLst/>
+          </a:prstGeom>
+          <a:noFill/>
+        </p:spPr>
+        <p:txBody>
+          <a:bodyPr wrap="square" anchor="t" lIns="0" rIns="0" tIns="0" bIns="0">
+            <a:spAutoFit/>
+          </a:bodyPr>
+          <a:lstStyle/>
+          <a:p>
+            <a:pPr algn="l">
+              <a:lnSpc>
+                <a:spcPct val="118000"/>
+              </a:lnSpc>
+              <a:spcAft>
+                <a:spcPts val="0"/>
+              </a:spcAft>
+            </a:pPr>
+            <a:r>
+              <a:rPr sz="950" b="1">
+                <a:solidFill>
+                  <a:srgbClr val="0E7490"/>
+                </a:solidFill>
+                <a:latin typeface="Inter"/>
+              </a:rPr>
+              <a:t>LITERATURE — SOC, RUL AND FAULT GRADING</a:t>
+            </a:r>
+          </a:p>
+        </p:txBody>
+      </p:sp>
+      <p:sp>
+        <p:nvSpPr>
+          <p:cNvPr id="8" name="Rectangle 7"/>
+          <p:cNvSpPr/>
+          <p:nvPr/>
+        </p:nvSpPr>
+        <p:spPr>
+          <a:xfrm>
+            <a:off x="566928" y="1769363"/>
+            <a:ext cx="237744" cy="237744"/>
+          </a:xfrm>
+          <a:prstGeom prst="rect">
+            <a:avLst/>
+          </a:prstGeom>
+          <a:solidFill>
+            <a:srgbClr val="F1F5F9"/>
+          </a:solidFill>
+          <a:ln w="7620">
+            <a:solidFill>
+              <a:srgbClr val="CBD5E1"/>
+            </a:solidFill>
+          </a:ln>
+          <a:effectLst/>
+        </p:spPr>
+        <p:style>
+          <a:lnRef idx="1">
+            <a:schemeClr val="accent1"/>
+          </a:lnRef>
+          <a:fillRef idx="3">
+            <a:schemeClr val="accent1"/>
+          </a:fillRef>
+          <a:effectRef idx="2">
+            <a:schemeClr val="accent1"/>
+          </a:effectRef>
+          <a:fontRef idx="minor">
+            <a:schemeClr val="lt1"/>
+          </a:fontRef>
+        </p:style>
+        <p:txBody>
+          <a:bodyPr rtlCol="0" anchor="ctr"/>
+          <a:lstStyle/>
+          <a:p/>
+        </p:txBody>
+      </p:sp>
+      <p:sp>
+        <p:nvSpPr>
+          <p:cNvPr id="9" name="TextBox 8"/>
+          <p:cNvSpPr txBox="1"/>
+          <p:nvPr/>
+        </p:nvSpPr>
+        <p:spPr>
+          <a:xfrm>
+            <a:off x="566928" y="1769363"/>
+            <a:ext cx="237744" cy="237744"/>
+          </a:xfrm>
+          <a:prstGeom prst="rect">
+            <a:avLst/>
+          </a:prstGeom>
+          <a:noFill/>
+        </p:spPr>
+        <p:txBody>
+          <a:bodyPr wrap="square" anchor="ctr" lIns="0" rIns="0" tIns="0" bIns="0">
+            <a:spAutoFit/>
+          </a:bodyPr>
+          <a:lstStyle/>
+          <a:p>
+            <a:pPr algn="ctr">
+              <a:lnSpc>
+                <a:spcPct val="118000"/>
+              </a:lnSpc>
+              <a:spcAft>
+                <a:spcPts val="0"/>
+              </a:spcAft>
+            </a:pPr>
+            <a:r>
+              <a:rPr sz="1000" b="1">
+                <a:solidFill>
+                  <a:srgbClr val="0E7490"/>
+                </a:solidFill>
+                <a:latin typeface="Inter"/>
+              </a:rPr>
+              <a:t>1</a:t>
+            </a:r>
+          </a:p>
+        </p:txBody>
+      </p:sp>
+      <p:sp>
+        <p:nvSpPr>
+          <p:cNvPr id="10" name="TextBox 9"/>
+          <p:cNvSpPr txBox="1"/>
+          <p:nvPr/>
+        </p:nvSpPr>
+        <p:spPr>
+          <a:xfrm>
+            <a:off x="932688" y="1755648"/>
+            <a:ext cx="5431536" cy="274320"/>
+          </a:xfrm>
+          <a:prstGeom prst="rect">
+            <a:avLst/>
+          </a:prstGeom>
+          <a:noFill/>
+        </p:spPr>
+        <p:txBody>
+          <a:bodyPr wrap="square" anchor="t" lIns="0" rIns="0" tIns="0" bIns="0">
+            <a:spAutoFit/>
+          </a:bodyPr>
+          <a:lstStyle/>
+          <a:p>
+            <a:pPr algn="l">
+              <a:lnSpc>
+                <a:spcPct val="122000"/>
+              </a:lnSpc>
+              <a:spcAft>
+                <a:spcPts val="0"/>
+              </a:spcAft>
+            </a:pPr>
+            <a:r>
+              <a:rPr sz="1150" b="0">
+                <a:solidFill>
+                  <a:srgbClr val="0F172A"/>
+                </a:solidFill>
+                <a:latin typeface="Inter"/>
+              </a:rPr>
+              <a:t>Bimodal images + BFRN</a:t>
+            </a:r>
+          </a:p>
+        </p:txBody>
+      </p:sp>
+      <p:sp>
+        <p:nvSpPr>
+          <p:cNvPr id="11" name="TextBox 10"/>
+          <p:cNvSpPr txBox="1"/>
+          <p:nvPr/>
+        </p:nvSpPr>
+        <p:spPr>
+          <a:xfrm>
+            <a:off x="932688" y="2011680"/>
+            <a:ext cx="5431536" cy="201168"/>
+          </a:xfrm>
+          <a:prstGeom prst="rect">
+            <a:avLst/>
+          </a:prstGeom>
+          <a:noFill/>
+        </p:spPr>
+        <p:txBody>
+          <a:bodyPr wrap="square" anchor="t" lIns="0" rIns="0" tIns="0" bIns="0">
+            <a:spAutoFit/>
+          </a:bodyPr>
+          <a:lstStyle/>
+          <a:p>
+            <a:pPr algn="l">
+              <a:lnSpc>
+                <a:spcPct val="118000"/>
+              </a:lnSpc>
+              <a:spcAft>
+                <a:spcPts val="0"/>
+              </a:spcAft>
+            </a:pPr>
+            <a:r>
+              <a:rPr sz="900" b="0">
+                <a:solidFill>
+                  <a:srgbClr val="475569"/>
+                </a:solidFill>
+                <a:latin typeface="Inter"/>
+              </a:rPr>
+              <a:t>Energy, 2024  ·  doi.org/10.1016/j.energy.2024.131700</a:t>
+            </a:r>
+          </a:p>
+        </p:txBody>
+      </p:sp>
+      <p:sp>
+        <p:nvSpPr>
+          <p:cNvPr id="12" name="Rectangle 11"/>
+          <p:cNvSpPr/>
+          <p:nvPr/>
+        </p:nvSpPr>
+        <p:spPr>
+          <a:xfrm>
+            <a:off x="566928" y="2391156"/>
+            <a:ext cx="237744" cy="237744"/>
+          </a:xfrm>
+          <a:prstGeom prst="rect">
+            <a:avLst/>
+          </a:prstGeom>
+          <a:solidFill>
+            <a:srgbClr val="F1F5F9"/>
+          </a:solidFill>
+          <a:ln w="7620">
+            <a:solidFill>
+              <a:srgbClr val="CBD5E1"/>
+            </a:solidFill>
+          </a:ln>
+          <a:effectLst/>
+        </p:spPr>
+        <p:style>
+          <a:lnRef idx="1">
+            <a:schemeClr val="accent1"/>
+          </a:lnRef>
+          <a:fillRef idx="3">
+            <a:schemeClr val="accent1"/>
+          </a:fillRef>
+          <a:effectRef idx="2">
+            <a:schemeClr val="accent1"/>
+          </a:effectRef>
+          <a:fontRef idx="minor">
+            <a:schemeClr val="lt1"/>
+          </a:fontRef>
+        </p:style>
+        <p:txBody>
+          <a:bodyPr rtlCol="0" anchor="ctr"/>
+          <a:lstStyle/>
+          <a:p/>
+        </p:txBody>
+      </p:sp>
+      <p:sp>
+        <p:nvSpPr>
+          <p:cNvPr id="13" name="TextBox 12"/>
+          <p:cNvSpPr txBox="1"/>
+          <p:nvPr/>
+        </p:nvSpPr>
+        <p:spPr>
+          <a:xfrm>
+            <a:off x="566928" y="2391156"/>
+            <a:ext cx="237744" cy="237744"/>
+          </a:xfrm>
+          <a:prstGeom prst="rect">
+            <a:avLst/>
+          </a:prstGeom>
+          <a:noFill/>
+        </p:spPr>
+        <p:txBody>
+          <a:bodyPr wrap="square" anchor="ctr" lIns="0" rIns="0" tIns="0" bIns="0">
+            <a:spAutoFit/>
+          </a:bodyPr>
+          <a:lstStyle/>
+          <a:p>
+            <a:pPr algn="ctr">
+              <a:lnSpc>
+                <a:spcPct val="118000"/>
+              </a:lnSpc>
+              <a:spcAft>
+                <a:spcPts val="0"/>
+              </a:spcAft>
+            </a:pPr>
+            <a:r>
+              <a:rPr sz="1000" b="1">
+                <a:solidFill>
+                  <a:srgbClr val="0E7490"/>
+                </a:solidFill>
+                <a:latin typeface="Inter"/>
+              </a:rPr>
+              <a:t>2</a:t>
+            </a:r>
+          </a:p>
+        </p:txBody>
+      </p:sp>
+      <p:sp>
+        <p:nvSpPr>
+          <p:cNvPr id="14" name="TextBox 13"/>
+          <p:cNvSpPr txBox="1"/>
+          <p:nvPr/>
+        </p:nvSpPr>
+        <p:spPr>
+          <a:xfrm>
+            <a:off x="932688" y="2377439"/>
+            <a:ext cx="5431536" cy="274320"/>
+          </a:xfrm>
+          <a:prstGeom prst="rect">
+            <a:avLst/>
+          </a:prstGeom>
+          <a:noFill/>
+        </p:spPr>
+        <p:txBody>
+          <a:bodyPr wrap="square" anchor="t" lIns="0" rIns="0" tIns="0" bIns="0">
+            <a:spAutoFit/>
+          </a:bodyPr>
+          <a:lstStyle/>
+          <a:p>
+            <a:pPr algn="l">
+              <a:lnSpc>
+                <a:spcPct val="122000"/>
+              </a:lnSpc>
+              <a:spcAft>
+                <a:spcPts val="0"/>
+              </a:spcAft>
+            </a:pPr>
+            <a:r>
+              <a:rPr sz="1150" b="0">
+                <a:solidFill>
+                  <a:srgbClr val="0F172A"/>
+                </a:solidFill>
+                <a:latin typeface="Inter"/>
+              </a:rPr>
+              <a:t>Single-cycle charging</a:t>
+            </a:r>
+          </a:p>
+        </p:txBody>
+      </p:sp>
+      <p:sp>
+        <p:nvSpPr>
+          <p:cNvPr id="15" name="TextBox 14"/>
+          <p:cNvSpPr txBox="1"/>
+          <p:nvPr/>
+        </p:nvSpPr>
+        <p:spPr>
+          <a:xfrm>
+            <a:off x="932688" y="2633472"/>
+            <a:ext cx="5431536" cy="201168"/>
+          </a:xfrm>
+          <a:prstGeom prst="rect">
+            <a:avLst/>
+          </a:prstGeom>
+          <a:noFill/>
+        </p:spPr>
+        <p:txBody>
+          <a:bodyPr wrap="square" anchor="t" lIns="0" rIns="0" tIns="0" bIns="0">
+            <a:spAutoFit/>
+          </a:bodyPr>
+          <a:lstStyle/>
+          <a:p>
+            <a:pPr algn="l">
+              <a:lnSpc>
+                <a:spcPct val="118000"/>
+              </a:lnSpc>
+              <a:spcAft>
+                <a:spcPts val="0"/>
+              </a:spcAft>
+            </a:pPr>
+            <a:r>
+              <a:rPr sz="900" b="0">
+                <a:solidFill>
+                  <a:srgbClr val="475569"/>
+                </a:solidFill>
+                <a:latin typeface="Inter"/>
+              </a:rPr>
+              <a:t>Energy, 2025  ·  doi.org/10.1016/j.energy.2025.138351</a:t>
+            </a:r>
+          </a:p>
+        </p:txBody>
+      </p:sp>
+      <p:sp>
+        <p:nvSpPr>
+          <p:cNvPr id="16" name="Rectangle 15"/>
+          <p:cNvSpPr/>
+          <p:nvPr/>
+        </p:nvSpPr>
+        <p:spPr>
+          <a:xfrm>
+            <a:off x="566928" y="3012947"/>
+            <a:ext cx="237744" cy="237744"/>
+          </a:xfrm>
+          <a:prstGeom prst="rect">
+            <a:avLst/>
+          </a:prstGeom>
+          <a:solidFill>
+            <a:srgbClr val="F1F5F9"/>
+          </a:solidFill>
+          <a:ln w="7620">
+            <a:solidFill>
+              <a:srgbClr val="CBD5E1"/>
+            </a:solidFill>
+          </a:ln>
+          <a:effectLst/>
+        </p:spPr>
+        <p:style>
+          <a:lnRef idx="1">
+            <a:schemeClr val="accent1"/>
+          </a:lnRef>
+          <a:fillRef idx="3">
+            <a:schemeClr val="accent1"/>
+          </a:fillRef>
+          <a:effectRef idx="2">
+            <a:schemeClr val="accent1"/>
+          </a:effectRef>
+          <a:fontRef idx="minor">
+            <a:schemeClr val="lt1"/>
+          </a:fontRef>
+        </p:style>
+        <p:txBody>
+          <a:bodyPr rtlCol="0" anchor="ctr"/>
+          <a:lstStyle/>
+          <a:p/>
+        </p:txBody>
+      </p:sp>
+      <p:sp>
+        <p:nvSpPr>
+          <p:cNvPr id="17" name="TextBox 16"/>
+          <p:cNvSpPr txBox="1"/>
+          <p:nvPr/>
+        </p:nvSpPr>
+        <p:spPr>
+          <a:xfrm>
+            <a:off x="566928" y="3012947"/>
+            <a:ext cx="237744" cy="237744"/>
+          </a:xfrm>
+          <a:prstGeom prst="rect">
+            <a:avLst/>
+          </a:prstGeom>
+          <a:noFill/>
+        </p:spPr>
+        <p:txBody>
+          <a:bodyPr wrap="square" anchor="ctr" lIns="0" rIns="0" tIns="0" bIns="0">
+            <a:spAutoFit/>
+          </a:bodyPr>
+          <a:lstStyle/>
+          <a:p>
+            <a:pPr algn="ctr">
+              <a:lnSpc>
+                <a:spcPct val="118000"/>
+              </a:lnSpc>
+              <a:spcAft>
+                <a:spcPts val="0"/>
+              </a:spcAft>
+            </a:pPr>
+            <a:r>
+              <a:rPr sz="1000" b="1">
+                <a:solidFill>
+                  <a:srgbClr val="0E7490"/>
+                </a:solidFill>
+                <a:latin typeface="Inter"/>
+              </a:rPr>
+              <a:t>3</a:t>
+            </a:r>
+          </a:p>
+        </p:txBody>
+      </p:sp>
+      <p:sp>
+        <p:nvSpPr>
+          <p:cNvPr id="18" name="TextBox 17"/>
+          <p:cNvSpPr txBox="1"/>
+          <p:nvPr/>
+        </p:nvSpPr>
+        <p:spPr>
+          <a:xfrm>
+            <a:off x="932688" y="2999231"/>
+            <a:ext cx="5431536" cy="274320"/>
+          </a:xfrm>
+          <a:prstGeom prst="rect">
+            <a:avLst/>
+          </a:prstGeom>
+          <a:noFill/>
+        </p:spPr>
+        <p:txBody>
+          <a:bodyPr wrap="square" anchor="t" lIns="0" rIns="0" tIns="0" bIns="0">
+            <a:spAutoFit/>
+          </a:bodyPr>
+          <a:lstStyle/>
+          <a:p>
+            <a:pPr algn="l">
+              <a:lnSpc>
+                <a:spcPct val="122000"/>
+              </a:lnSpc>
+              <a:spcAft>
+                <a:spcPts val="0"/>
+              </a:spcAft>
+            </a:pPr>
+            <a:r>
+              <a:rPr sz="1150" b="0">
+                <a:solidFill>
+                  <a:srgbClr val="0F172A"/>
+                </a:solidFill>
+                <a:latin typeface="Inter"/>
+              </a:rPr>
+              <a:t>Multidomain features + CatBoost</a:t>
+            </a:r>
+          </a:p>
+        </p:txBody>
+      </p:sp>
+      <p:sp>
+        <p:nvSpPr>
+          <p:cNvPr id="19" name="TextBox 18"/>
+          <p:cNvSpPr txBox="1"/>
+          <p:nvPr/>
+        </p:nvSpPr>
+        <p:spPr>
+          <a:xfrm>
+            <a:off x="932688" y="3255263"/>
+            <a:ext cx="5431536" cy="201168"/>
+          </a:xfrm>
+          <a:prstGeom prst="rect">
+            <a:avLst/>
+          </a:prstGeom>
+          <a:noFill/>
+        </p:spPr>
+        <p:txBody>
+          <a:bodyPr wrap="square" anchor="t" lIns="0" rIns="0" tIns="0" bIns="0">
+            <a:spAutoFit/>
+          </a:bodyPr>
+          <a:lstStyle/>
+          <a:p>
+            <a:pPr algn="l">
+              <a:lnSpc>
+                <a:spcPct val="118000"/>
+              </a:lnSpc>
+              <a:spcAft>
+                <a:spcPts val="0"/>
+              </a:spcAft>
+            </a:pPr>
+            <a:r>
+              <a:rPr sz="900" b="0">
+                <a:solidFill>
+                  <a:srgbClr val="475569"/>
+                </a:solidFill>
+                <a:latin typeface="Inter"/>
+              </a:rPr>
+              <a:t>Energy Science &amp; Engineering, 2023  ·  doi.org/10.1002/ese3.1506</a:t>
+            </a:r>
+          </a:p>
+        </p:txBody>
+      </p:sp>
+      <p:sp>
+        <p:nvSpPr>
+          <p:cNvPr id="20" name="Rectangle 19"/>
+          <p:cNvSpPr/>
+          <p:nvPr/>
+        </p:nvSpPr>
+        <p:spPr>
+          <a:xfrm>
+            <a:off x="566928" y="3634739"/>
+            <a:ext cx="237744" cy="237744"/>
+          </a:xfrm>
+          <a:prstGeom prst="rect">
+            <a:avLst/>
+          </a:prstGeom>
+          <a:solidFill>
+            <a:srgbClr val="F1F5F9"/>
+          </a:solidFill>
+          <a:ln w="7620">
+            <a:solidFill>
+              <a:srgbClr val="CBD5E1"/>
+            </a:solidFill>
+          </a:ln>
+          <a:effectLst/>
+        </p:spPr>
+        <p:style>
+          <a:lnRef idx="1">
+            <a:schemeClr val="accent1"/>
+          </a:lnRef>
+          <a:fillRef idx="3">
+            <a:schemeClr val="accent1"/>
+          </a:fillRef>
+          <a:effectRef idx="2">
+            <a:schemeClr val="accent1"/>
+          </a:effectRef>
+          <a:fontRef idx="minor">
+            <a:schemeClr val="lt1"/>
+          </a:fontRef>
+        </p:style>
+        <p:txBody>
+          <a:bodyPr rtlCol="0" anchor="ctr"/>
+          <a:lstStyle/>
+          <a:p/>
+        </p:txBody>
+      </p:sp>
+      <p:sp>
+        <p:nvSpPr>
+          <p:cNvPr id="21" name="TextBox 20"/>
+          <p:cNvSpPr txBox="1"/>
+          <p:nvPr/>
+        </p:nvSpPr>
+        <p:spPr>
+          <a:xfrm>
+            <a:off x="566928" y="3634739"/>
+            <a:ext cx="237744" cy="237744"/>
+          </a:xfrm>
+          <a:prstGeom prst="rect">
+            <a:avLst/>
+          </a:prstGeom>
+          <a:noFill/>
+        </p:spPr>
+        <p:txBody>
+          <a:bodyPr wrap="square" anchor="ctr" lIns="0" rIns="0" tIns="0" bIns="0">
+            <a:spAutoFit/>
+          </a:bodyPr>
+          <a:lstStyle/>
+          <a:p>
+            <a:pPr algn="ctr">
+              <a:lnSpc>
+                <a:spcPct val="118000"/>
+              </a:lnSpc>
+              <a:spcAft>
+                <a:spcPts val="0"/>
+              </a:spcAft>
+            </a:pPr>
+            <a:r>
+              <a:rPr sz="1000" b="1">
+                <a:solidFill>
+                  <a:srgbClr val="0E7490"/>
+                </a:solidFill>
+                <a:latin typeface="Inter"/>
+              </a:rPr>
+              <a:t>4</a:t>
+            </a:r>
+          </a:p>
+        </p:txBody>
+      </p:sp>
+      <p:sp>
+        <p:nvSpPr>
+          <p:cNvPr id="22" name="TextBox 21"/>
+          <p:cNvSpPr txBox="1"/>
+          <p:nvPr/>
+        </p:nvSpPr>
+        <p:spPr>
+          <a:xfrm>
+            <a:off x="932688" y="3621023"/>
+            <a:ext cx="5431536" cy="274320"/>
+          </a:xfrm>
+          <a:prstGeom prst="rect">
+            <a:avLst/>
+          </a:prstGeom>
+          <a:noFill/>
+        </p:spPr>
+        <p:txBody>
+          <a:bodyPr wrap="square" anchor="t" lIns="0" rIns="0" tIns="0" bIns="0">
+            <a:spAutoFit/>
+          </a:bodyPr>
+          <a:lstStyle/>
+          <a:p>
+            <a:pPr algn="l">
+              <a:lnSpc>
+                <a:spcPct val="122000"/>
+              </a:lnSpc>
+              <a:spcAft>
+                <a:spcPts val="0"/>
+              </a:spcAft>
+            </a:pPr>
+            <a:r>
+              <a:rPr sz="1150" b="0">
+                <a:solidFill>
+                  <a:srgbClr val="0F172A"/>
+                </a:solidFill>
+                <a:latin typeface="Inter"/>
+              </a:rPr>
+              <a:t>CNN-BiLSTM-BiGRU with attention</a:t>
+            </a:r>
+          </a:p>
+        </p:txBody>
+      </p:sp>
+      <p:sp>
+        <p:nvSpPr>
+          <p:cNvPr id="23" name="TextBox 22"/>
+          <p:cNvSpPr txBox="1"/>
+          <p:nvPr/>
+        </p:nvSpPr>
+        <p:spPr>
+          <a:xfrm>
+            <a:off x="932688" y="3877055"/>
+            <a:ext cx="5431536" cy="201168"/>
+          </a:xfrm>
+          <a:prstGeom prst="rect">
+            <a:avLst/>
+          </a:prstGeom>
+          <a:noFill/>
+        </p:spPr>
+        <p:txBody>
+          <a:bodyPr wrap="square" anchor="t" lIns="0" rIns="0" tIns="0" bIns="0">
+            <a:spAutoFit/>
+          </a:bodyPr>
+          <a:lstStyle/>
+          <a:p>
+            <a:pPr algn="l">
+              <a:lnSpc>
+                <a:spcPct val="118000"/>
+              </a:lnSpc>
+              <a:spcAft>
+                <a:spcPts val="0"/>
+              </a:spcAft>
+            </a:pPr>
+            <a:r>
+              <a:rPr sz="900" b="0">
+                <a:solidFill>
+                  <a:srgbClr val="475569"/>
+                </a:solidFill>
+                <a:latin typeface="Inter"/>
+              </a:rPr>
+              <a:t>Journal of Energy Storage, 2024  ·  doi.org/10.1016/j.est.2024.113074</a:t>
+            </a:r>
+          </a:p>
+        </p:txBody>
+      </p:sp>
+      <p:sp>
+        <p:nvSpPr>
+          <p:cNvPr id="24" name="Rectangle 23"/>
+          <p:cNvSpPr/>
+          <p:nvPr/>
+        </p:nvSpPr>
+        <p:spPr>
+          <a:xfrm>
+            <a:off x="566928" y="4256531"/>
+            <a:ext cx="237744" cy="237744"/>
+          </a:xfrm>
+          <a:prstGeom prst="rect">
+            <a:avLst/>
+          </a:prstGeom>
+          <a:solidFill>
+            <a:srgbClr val="F1F5F9"/>
+          </a:solidFill>
+          <a:ln w="7620">
+            <a:solidFill>
+              <a:srgbClr val="CBD5E1"/>
+            </a:solidFill>
+          </a:ln>
+          <a:effectLst/>
+        </p:spPr>
+        <p:style>
+          <a:lnRef idx="1">
+            <a:schemeClr val="accent1"/>
+          </a:lnRef>
+          <a:fillRef idx="3">
+            <a:schemeClr val="accent1"/>
+          </a:fillRef>
+          <a:effectRef idx="2">
+            <a:schemeClr val="accent1"/>
+          </a:effectRef>
+          <a:fontRef idx="minor">
+            <a:schemeClr val="lt1"/>
+          </a:fontRef>
+        </p:style>
+        <p:txBody>
+          <a:bodyPr rtlCol="0" anchor="ctr"/>
+          <a:lstStyle/>
+          <a:p/>
+        </p:txBody>
+      </p:sp>
+      <p:sp>
+        <p:nvSpPr>
+          <p:cNvPr id="25" name="TextBox 24"/>
+          <p:cNvSpPr txBox="1"/>
+          <p:nvPr/>
+        </p:nvSpPr>
+        <p:spPr>
+          <a:xfrm>
+            <a:off x="566928" y="4256531"/>
+            <a:ext cx="237744" cy="237744"/>
+          </a:xfrm>
+          <a:prstGeom prst="rect">
+            <a:avLst/>
+          </a:prstGeom>
+          <a:noFill/>
+        </p:spPr>
+        <p:txBody>
+          <a:bodyPr wrap="square" anchor="ctr" lIns="0" rIns="0" tIns="0" bIns="0">
+            <a:spAutoFit/>
+          </a:bodyPr>
+          <a:lstStyle/>
+          <a:p>
+            <a:pPr algn="ctr">
+              <a:lnSpc>
+                <a:spcPct val="118000"/>
+              </a:lnSpc>
+              <a:spcAft>
+                <a:spcPts val="0"/>
+              </a:spcAft>
+            </a:pPr>
+            <a:r>
+              <a:rPr sz="1000" b="1">
+                <a:solidFill>
+                  <a:srgbClr val="0E7490"/>
+                </a:solidFill>
+                <a:latin typeface="Inter"/>
+              </a:rPr>
+              <a:t>5</a:t>
+            </a:r>
+          </a:p>
+        </p:txBody>
+      </p:sp>
+      <p:sp>
+        <p:nvSpPr>
+          <p:cNvPr id="26" name="TextBox 25"/>
+          <p:cNvSpPr txBox="1"/>
+          <p:nvPr/>
+        </p:nvSpPr>
+        <p:spPr>
+          <a:xfrm>
+            <a:off x="932688" y="4242815"/>
+            <a:ext cx="5431536" cy="493776"/>
+          </a:xfrm>
+          <a:prstGeom prst="rect">
+            <a:avLst/>
+          </a:prstGeom>
+          <a:noFill/>
+        </p:spPr>
+        <p:txBody>
+          <a:bodyPr wrap="square" anchor="t" lIns="0" rIns="0" tIns="0" bIns="0">
+            <a:spAutoFit/>
+          </a:bodyPr>
+          <a:lstStyle/>
+          <a:p>
+            <a:pPr algn="l">
+              <a:lnSpc>
+                <a:spcPct val="122000"/>
+              </a:lnSpc>
+              <a:spcAft>
+                <a:spcPts val="0"/>
+              </a:spcAft>
+            </a:pPr>
+            <a:r>
+              <a:rPr sz="1150" b="0">
+                <a:solidFill>
+                  <a:srgbClr val="0F172A"/>
+                </a:solidFill>
+                <a:latin typeface="Inter"/>
+              </a:rPr>
+              <a:t>Yang, S., Xu, B., Peng, H. — “Isolation and Grading of Faults in
+Battery Packs Based on Machine Learning Methods”</a:t>
+            </a:r>
+          </a:p>
+        </p:txBody>
+      </p:sp>
+      <p:sp>
+        <p:nvSpPr>
+          <p:cNvPr id="27" name="TextBox 26"/>
+          <p:cNvSpPr txBox="1"/>
+          <p:nvPr/>
+        </p:nvSpPr>
+        <p:spPr>
+          <a:xfrm>
+            <a:off x="932688" y="4718303"/>
+            <a:ext cx="5431536" cy="201168"/>
+          </a:xfrm>
+          <a:prstGeom prst="rect">
+            <a:avLst/>
+          </a:prstGeom>
+          <a:noFill/>
+        </p:spPr>
+        <p:txBody>
+          <a:bodyPr wrap="square" anchor="t" lIns="0" rIns="0" tIns="0" bIns="0">
+            <a:spAutoFit/>
+          </a:bodyPr>
+          <a:lstStyle/>
+          <a:p>
+            <a:pPr algn="l">
+              <a:lnSpc>
+                <a:spcPct val="118000"/>
+              </a:lnSpc>
+              <a:spcAft>
+                <a:spcPts val="0"/>
+              </a:spcAft>
+            </a:pPr>
+            <a:r>
+              <a:rPr sz="900" b="0">
+                <a:solidFill>
+                  <a:srgbClr val="475569"/>
+                </a:solidFill>
+                <a:latin typeface="Inter"/>
+              </a:rPr>
+              <a:t>Electronics, 11(9), 1494, 2022  ·  mdpi.com/2079-9292/11/9/1494</a:t>
+            </a:r>
+          </a:p>
+        </p:txBody>
+      </p:sp>
+      <p:sp>
+        <p:nvSpPr>
+          <p:cNvPr id="28" name="Rectangle 27"/>
+          <p:cNvSpPr/>
+          <p:nvPr/>
+        </p:nvSpPr>
+        <p:spPr>
+          <a:xfrm>
+            <a:off x="6693408" y="1444752"/>
+            <a:ext cx="4931359" cy="2139696"/>
+          </a:xfrm>
+          <a:prstGeom prst="rect">
+            <a:avLst/>
+          </a:prstGeom>
+          <a:solidFill>
+            <a:srgbClr val="F1F5F9"/>
+          </a:solidFill>
+          <a:ln w="9525">
+            <a:solidFill>
+              <a:srgbClr val="CBD5E1"/>
+            </a:solidFill>
+          </a:ln>
+          <a:effectLst/>
+        </p:spPr>
+        <p:style>
+          <a:lnRef idx="1">
+            <a:schemeClr val="accent1"/>
+          </a:lnRef>
+          <a:fillRef idx="3">
+            <a:schemeClr val="accent1"/>
+          </a:fillRef>
+          <a:effectRef idx="2">
+            <a:schemeClr val="accent1"/>
+          </a:effectRef>
+          <a:fontRef idx="minor">
+            <a:schemeClr val="lt1"/>
+          </a:fontRef>
+        </p:style>
+        <p:txBody>
+          <a:bodyPr rtlCol="0" anchor="ctr"/>
+          <a:lstStyle/>
+          <a:p/>
+        </p:txBody>
+      </p:sp>
+      <p:sp>
+        <p:nvSpPr>
+          <p:cNvPr id="29" name="TextBox 28"/>
+          <p:cNvSpPr txBox="1"/>
+          <p:nvPr/>
+        </p:nvSpPr>
+        <p:spPr>
+          <a:xfrm>
+            <a:off x="6894576" y="1572768"/>
+            <a:ext cx="4529023" cy="219456"/>
+          </a:xfrm>
+          <a:prstGeom prst="rect">
+            <a:avLst/>
+          </a:prstGeom>
+          <a:noFill/>
+        </p:spPr>
+        <p:txBody>
+          <a:bodyPr wrap="square" anchor="t" lIns="0" rIns="0" tIns="0" bIns="0">
+            <a:spAutoFit/>
+          </a:bodyPr>
+          <a:lstStyle/>
+          <a:p>
+            <a:pPr algn="l">
+              <a:lnSpc>
+                <a:spcPct val="118000"/>
+              </a:lnSpc>
+              <a:spcAft>
+                <a:spcPts val="0"/>
+              </a:spcAft>
+            </a:pPr>
+            <a:r>
+              <a:rPr sz="950" b="1">
+                <a:solidFill>
+                  <a:srgbClr val="0E7490"/>
+                </a:solidFill>
+                <a:latin typeface="Inter"/>
+              </a:rPr>
+              <a:t>PRIMARY SOURCES — MANUFACTURER DATASHEETS</a:t>
+            </a:r>
+          </a:p>
+        </p:txBody>
+      </p:sp>
+      <p:sp>
+        <p:nvSpPr>
+          <p:cNvPr id="30" name="Oval 29"/>
+          <p:cNvSpPr/>
+          <p:nvPr/>
+        </p:nvSpPr>
+        <p:spPr>
+          <a:xfrm>
+            <a:off x="6912864" y="1947672"/>
+            <a:ext cx="82296" cy="82296"/>
+          </a:xfrm>
+          <a:prstGeom prst="ellipse">
+            <a:avLst/>
+          </a:prstGeom>
+          <a:solidFill>
+            <a:srgbClr val="0E7490"/>
+          </a:solidFill>
+          <a:ln>
+            <a:noFill/>
+          </a:ln>
+          <a:effectLst/>
+        </p:spPr>
+        <p:style>
+          <a:lnRef idx="1">
+            <a:schemeClr val="accent1"/>
+          </a:lnRef>
+          <a:fillRef idx="3">
+            <a:schemeClr val="accent1"/>
+          </a:fillRef>
+          <a:effectRef idx="2">
+            <a:schemeClr val="accent1"/>
+          </a:effectRef>
+          <a:fontRef idx="minor">
+            <a:schemeClr val="lt1"/>
+          </a:fontRef>
+        </p:style>
+        <p:txBody>
+          <a:bodyPr rtlCol="0" anchor="ctr"/>
+          <a:lstStyle/>
+          <a:p/>
+        </p:txBody>
+      </p:sp>
+      <p:sp>
+        <p:nvSpPr>
+          <p:cNvPr id="31" name="TextBox 30"/>
+          <p:cNvSpPr txBox="1"/>
+          <p:nvPr/>
+        </p:nvSpPr>
+        <p:spPr>
+          <a:xfrm>
+            <a:off x="7114032" y="1865376"/>
+            <a:ext cx="2788920" cy="237744"/>
+          </a:xfrm>
+          <a:prstGeom prst="rect">
+            <a:avLst/>
+          </a:prstGeom>
+          <a:noFill/>
+        </p:spPr>
+        <p:txBody>
+          <a:bodyPr wrap="square" anchor="t" lIns="0" rIns="0" tIns="0" bIns="0">
+            <a:spAutoFit/>
+          </a:bodyPr>
+          <a:lstStyle/>
+          <a:p>
+            <a:pPr algn="l">
+              <a:lnSpc>
+                <a:spcPct val="118000"/>
+              </a:lnSpc>
+              <a:spcAft>
+                <a:spcPts val="0"/>
+              </a:spcAft>
+            </a:pPr>
+            <a:r>
+              <a:rPr sz="1050" b="0">
+                <a:solidFill>
+                  <a:srgbClr val="0F172A"/>
+                </a:solidFill>
+                <a:latin typeface="Inter"/>
+              </a:rPr>
+              <a:t>LG Energy Solution INR21700-M50</a:t>
+            </a:r>
+          </a:p>
+        </p:txBody>
+      </p:sp>
+      <p:sp>
+        <p:nvSpPr>
+          <p:cNvPr id="32" name="TextBox 31"/>
+          <p:cNvSpPr txBox="1"/>
+          <p:nvPr/>
+        </p:nvSpPr>
+        <p:spPr>
+          <a:xfrm>
+            <a:off x="9893808" y="1874519"/>
+            <a:ext cx="1529791" cy="219456"/>
+          </a:xfrm>
+          <a:prstGeom prst="rect">
+            <a:avLst/>
+          </a:prstGeom>
+          <a:noFill/>
+        </p:spPr>
+        <p:txBody>
+          <a:bodyPr wrap="square" anchor="t" lIns="0" rIns="0" tIns="0" bIns="0">
+            <a:spAutoFit/>
+          </a:bodyPr>
+          <a:lstStyle/>
+          <a:p>
+            <a:pPr algn="l">
+              <a:lnSpc>
+                <a:spcPct val="118000"/>
+              </a:lnSpc>
+              <a:spcAft>
+                <a:spcPts val="0"/>
+              </a:spcAft>
+            </a:pPr>
+            <a:r>
+              <a:rPr sz="900" b="0">
+                <a:solidFill>
+                  <a:srgbClr val="475569"/>
+                </a:solidFill>
+                <a:latin typeface="Inter"/>
+              </a:rPr>
+              <a:t>cell used in the 8S2P pack</a:t>
+            </a:r>
+          </a:p>
+        </p:txBody>
+      </p:sp>
+      <p:sp>
+        <p:nvSpPr>
+          <p:cNvPr id="33" name="Oval 32"/>
+          <p:cNvSpPr/>
+          <p:nvPr/>
+        </p:nvSpPr>
+        <p:spPr>
+          <a:xfrm>
+            <a:off x="6912864" y="2295144"/>
+            <a:ext cx="82296" cy="82296"/>
+          </a:xfrm>
+          <a:prstGeom prst="ellipse">
+            <a:avLst/>
+          </a:prstGeom>
+          <a:solidFill>
+            <a:srgbClr val="0E7490"/>
+          </a:solidFill>
+          <a:ln>
+            <a:noFill/>
+          </a:ln>
+          <a:effectLst/>
+        </p:spPr>
+        <p:style>
+          <a:lnRef idx="1">
+            <a:schemeClr val="accent1"/>
+          </a:lnRef>
+          <a:fillRef idx="3">
+            <a:schemeClr val="accent1"/>
+          </a:fillRef>
+          <a:effectRef idx="2">
+            <a:schemeClr val="accent1"/>
+          </a:effectRef>
+          <a:fontRef idx="minor">
+            <a:schemeClr val="lt1"/>
+          </a:fontRef>
+        </p:style>
+        <p:txBody>
+          <a:bodyPr rtlCol="0" anchor="ctr"/>
+          <a:lstStyle/>
+          <a:p/>
+        </p:txBody>
+      </p:sp>
+      <p:sp>
+        <p:nvSpPr>
+          <p:cNvPr id="34" name="TextBox 33"/>
+          <p:cNvSpPr txBox="1"/>
+          <p:nvPr/>
+        </p:nvSpPr>
+        <p:spPr>
+          <a:xfrm>
+            <a:off x="7114032" y="2212848"/>
+            <a:ext cx="2788920" cy="237744"/>
+          </a:xfrm>
+          <a:prstGeom prst="rect">
+            <a:avLst/>
+          </a:prstGeom>
+          <a:noFill/>
+        </p:spPr>
+        <p:txBody>
+          <a:bodyPr wrap="square" anchor="t" lIns="0" rIns="0" tIns="0" bIns="0">
+            <a:spAutoFit/>
+          </a:bodyPr>
+          <a:lstStyle/>
+          <a:p>
+            <a:pPr algn="l">
+              <a:lnSpc>
+                <a:spcPct val="118000"/>
+              </a:lnSpc>
+              <a:spcAft>
+                <a:spcPts val="0"/>
+              </a:spcAft>
+            </a:pPr>
+            <a:r>
+              <a:rPr sz="1050" b="0">
+                <a:solidFill>
+                  <a:srgbClr val="0F172A"/>
+                </a:solidFill>
+                <a:latin typeface="Inter"/>
+              </a:rPr>
+              <a:t>DMEGC INR21700-45E</a:t>
+            </a:r>
+          </a:p>
+        </p:txBody>
+      </p:sp>
+      <p:sp>
+        <p:nvSpPr>
+          <p:cNvPr id="35" name="TextBox 34"/>
+          <p:cNvSpPr txBox="1"/>
+          <p:nvPr/>
+        </p:nvSpPr>
+        <p:spPr>
+          <a:xfrm>
+            <a:off x="9893808" y="2221991"/>
+            <a:ext cx="1529791" cy="219456"/>
+          </a:xfrm>
+          <a:prstGeom prst="rect">
+            <a:avLst/>
+          </a:prstGeom>
+          <a:noFill/>
+        </p:spPr>
+        <p:txBody>
+          <a:bodyPr wrap="square" anchor="t" lIns="0" rIns="0" tIns="0" bIns="0">
+            <a:spAutoFit/>
+          </a:bodyPr>
+          <a:lstStyle/>
+          <a:p>
+            <a:pPr algn="l">
+              <a:lnSpc>
+                <a:spcPct val="118000"/>
+              </a:lnSpc>
+              <a:spcAft>
+                <a:spcPts val="0"/>
+              </a:spcAft>
+            </a:pPr>
+            <a:r>
+              <a:rPr sz="900" b="0">
+                <a:solidFill>
+                  <a:srgbClr val="475569"/>
+                </a:solidFill>
+                <a:latin typeface="Inter"/>
+              </a:rPr>
+              <a:t>alternate NMC cell, parsed</a:t>
+            </a:r>
+          </a:p>
+        </p:txBody>
+      </p:sp>
+      <p:sp>
+        <p:nvSpPr>
+          <p:cNvPr id="36" name="Oval 35"/>
+          <p:cNvSpPr/>
+          <p:nvPr/>
+        </p:nvSpPr>
+        <p:spPr>
+          <a:xfrm>
+            <a:off x="6912864" y="2642615"/>
+            <a:ext cx="82296" cy="82296"/>
+          </a:xfrm>
+          <a:prstGeom prst="ellipse">
+            <a:avLst/>
+          </a:prstGeom>
+          <a:solidFill>
+            <a:srgbClr val="0E7490"/>
+          </a:solidFill>
+          <a:ln>
+            <a:noFill/>
+          </a:ln>
+          <a:effectLst/>
+        </p:spPr>
+        <p:style>
+          <a:lnRef idx="1">
+            <a:schemeClr val="accent1"/>
+          </a:lnRef>
+          <a:fillRef idx="3">
+            <a:schemeClr val="accent1"/>
+          </a:fillRef>
+          <a:effectRef idx="2">
+            <a:schemeClr val="accent1"/>
+          </a:effectRef>
+          <a:fontRef idx="minor">
+            <a:schemeClr val="lt1"/>
+          </a:fontRef>
+        </p:style>
+        <p:txBody>
+          <a:bodyPr rtlCol="0" anchor="ctr"/>
+          <a:lstStyle/>
+          <a:p/>
+        </p:txBody>
+      </p:sp>
+      <p:sp>
+        <p:nvSpPr>
+          <p:cNvPr id="37" name="TextBox 36"/>
+          <p:cNvSpPr txBox="1"/>
+          <p:nvPr/>
+        </p:nvSpPr>
+        <p:spPr>
+          <a:xfrm>
+            <a:off x="7114032" y="2560320"/>
+            <a:ext cx="2788920" cy="237744"/>
+          </a:xfrm>
+          <a:prstGeom prst="rect">
+            <a:avLst/>
+          </a:prstGeom>
+          <a:noFill/>
+        </p:spPr>
+        <p:txBody>
+          <a:bodyPr wrap="square" anchor="t" lIns="0" rIns="0" tIns="0" bIns="0">
+            <a:spAutoFit/>
+          </a:bodyPr>
+          <a:lstStyle/>
+          <a:p>
+            <a:pPr algn="l">
+              <a:lnSpc>
+                <a:spcPct val="118000"/>
+              </a:lnSpc>
+              <a:spcAft>
+                <a:spcPts val="0"/>
+              </a:spcAft>
+            </a:pPr>
+            <a:r>
+              <a:rPr sz="1050" b="0">
+                <a:solidFill>
+                  <a:srgbClr val="0F172A"/>
+                </a:solidFill>
+                <a:latin typeface="Inter"/>
+              </a:rPr>
+              <a:t>Panasonic NCR18650B</a:t>
+            </a:r>
+          </a:p>
+        </p:txBody>
+      </p:sp>
+      <p:sp>
+        <p:nvSpPr>
+          <p:cNvPr id="38" name="TextBox 37"/>
+          <p:cNvSpPr txBox="1"/>
+          <p:nvPr/>
+        </p:nvSpPr>
+        <p:spPr>
+          <a:xfrm>
+            <a:off x="9893808" y="2569463"/>
+            <a:ext cx="1529791" cy="219456"/>
+          </a:xfrm>
+          <a:prstGeom prst="rect">
+            <a:avLst/>
+          </a:prstGeom>
+          <a:noFill/>
+        </p:spPr>
+        <p:txBody>
+          <a:bodyPr wrap="square" anchor="t" lIns="0" rIns="0" tIns="0" bIns="0">
+            <a:spAutoFit/>
+          </a:bodyPr>
+          <a:lstStyle/>
+          <a:p>
+            <a:pPr algn="l">
+              <a:lnSpc>
+                <a:spcPct val="118000"/>
+              </a:lnSpc>
+              <a:spcAft>
+                <a:spcPts val="0"/>
+              </a:spcAft>
+            </a:pPr>
+            <a:r>
+              <a:rPr sz="900" b="0">
+                <a:solidFill>
+                  <a:srgbClr val="475569"/>
+                </a:solidFill>
+                <a:latin typeface="Inter"/>
+              </a:rPr>
+              <a:t>NCA tier reference</a:t>
+            </a:r>
+          </a:p>
+        </p:txBody>
+      </p:sp>
+      <p:sp>
+        <p:nvSpPr>
+          <p:cNvPr id="39" name="Oval 38"/>
+          <p:cNvSpPr/>
+          <p:nvPr/>
+        </p:nvSpPr>
+        <p:spPr>
+          <a:xfrm>
+            <a:off x="6912864" y="2990087"/>
+            <a:ext cx="82296" cy="82296"/>
+          </a:xfrm>
+          <a:prstGeom prst="ellipse">
+            <a:avLst/>
+          </a:prstGeom>
+          <a:solidFill>
+            <a:srgbClr val="0E7490"/>
+          </a:solidFill>
+          <a:ln>
+            <a:noFill/>
+          </a:ln>
+          <a:effectLst/>
+        </p:spPr>
+        <p:style>
+          <a:lnRef idx="1">
+            <a:schemeClr val="accent1"/>
+          </a:lnRef>
+          <a:fillRef idx="3">
+            <a:schemeClr val="accent1"/>
+          </a:fillRef>
+          <a:effectRef idx="2">
+            <a:schemeClr val="accent1"/>
+          </a:effectRef>
+          <a:fontRef idx="minor">
+            <a:schemeClr val="lt1"/>
+          </a:fontRef>
+        </p:style>
+        <p:txBody>
+          <a:bodyPr rtlCol="0" anchor="ctr"/>
+          <a:lstStyle/>
+          <a:p/>
+        </p:txBody>
+      </p:sp>
+      <p:sp>
+        <p:nvSpPr>
+          <p:cNvPr id="40" name="TextBox 39"/>
+          <p:cNvSpPr txBox="1"/>
+          <p:nvPr/>
+        </p:nvSpPr>
+        <p:spPr>
+          <a:xfrm>
+            <a:off x="7114032" y="2907791"/>
+            <a:ext cx="2788920" cy="237744"/>
+          </a:xfrm>
+          <a:prstGeom prst="rect">
+            <a:avLst/>
+          </a:prstGeom>
+          <a:noFill/>
+        </p:spPr>
+        <p:txBody>
+          <a:bodyPr wrap="square" anchor="t" lIns="0" rIns="0" tIns="0" bIns="0">
+            <a:spAutoFit/>
+          </a:bodyPr>
+          <a:lstStyle/>
+          <a:p>
+            <a:pPr algn="l">
+              <a:lnSpc>
+                <a:spcPct val="118000"/>
+              </a:lnSpc>
+              <a:spcAft>
+                <a:spcPts val="0"/>
+              </a:spcAft>
+            </a:pPr>
+            <a:r>
+              <a:rPr sz="1050" b="0">
+                <a:solidFill>
+                  <a:srgbClr val="0F172A"/>
+                </a:solidFill>
+                <a:latin typeface="Inter"/>
+              </a:rPr>
+              <a:t>P3 3232 LFP 26650</a:t>
+            </a:r>
+          </a:p>
+        </p:txBody>
+      </p:sp>
+      <p:sp>
+        <p:nvSpPr>
+          <p:cNvPr id="41" name="TextBox 40"/>
+          <p:cNvSpPr txBox="1"/>
+          <p:nvPr/>
+        </p:nvSpPr>
+        <p:spPr>
+          <a:xfrm>
+            <a:off x="9893808" y="2916935"/>
+            <a:ext cx="1529791" cy="219456"/>
+          </a:xfrm>
+          <a:prstGeom prst="rect">
+            <a:avLst/>
+          </a:prstGeom>
+          <a:noFill/>
+        </p:spPr>
+        <p:txBody>
+          <a:bodyPr wrap="square" anchor="t" lIns="0" rIns="0" tIns="0" bIns="0">
+            <a:spAutoFit/>
+          </a:bodyPr>
+          <a:lstStyle/>
+          <a:p>
+            <a:pPr algn="l">
+              <a:lnSpc>
+                <a:spcPct val="118000"/>
+              </a:lnSpc>
+              <a:spcAft>
+                <a:spcPts val="0"/>
+              </a:spcAft>
+            </a:pPr>
+            <a:r>
+              <a:rPr sz="900" b="0">
+                <a:solidFill>
+                  <a:srgbClr val="475569"/>
+                </a:solidFill>
+                <a:latin typeface="Inter"/>
+              </a:rPr>
+              <a:t>LFP tier reference</a:t>
+            </a:r>
+          </a:p>
+        </p:txBody>
+      </p:sp>
+      <p:sp>
+        <p:nvSpPr>
+          <p:cNvPr id="42" name="Oval 41"/>
+          <p:cNvSpPr/>
+          <p:nvPr/>
+        </p:nvSpPr>
+        <p:spPr>
+          <a:xfrm>
+            <a:off x="6912864" y="3337559"/>
+            <a:ext cx="82296" cy="82296"/>
+          </a:xfrm>
+          <a:prstGeom prst="ellipse">
+            <a:avLst/>
+          </a:prstGeom>
+          <a:solidFill>
+            <a:srgbClr val="0E7490"/>
+          </a:solidFill>
+          <a:ln>
+            <a:noFill/>
+          </a:ln>
+          <a:effectLst/>
+        </p:spPr>
+        <p:style>
+          <a:lnRef idx="1">
+            <a:schemeClr val="accent1"/>
+          </a:lnRef>
+          <a:fillRef idx="3">
+            <a:schemeClr val="accent1"/>
+          </a:fillRef>
+          <a:effectRef idx="2">
+            <a:schemeClr val="accent1"/>
+          </a:effectRef>
+          <a:fontRef idx="minor">
+            <a:schemeClr val="lt1"/>
+          </a:fontRef>
+        </p:style>
+        <p:txBody>
+          <a:bodyPr rtlCol="0" anchor="ctr"/>
+          <a:lstStyle/>
+          <a:p/>
+        </p:txBody>
+      </p:sp>
+      <p:sp>
+        <p:nvSpPr>
+          <p:cNvPr id="43" name="TextBox 42"/>
+          <p:cNvSpPr txBox="1"/>
+          <p:nvPr/>
+        </p:nvSpPr>
+        <p:spPr>
+          <a:xfrm>
+            <a:off x="7114032" y="3255263"/>
+            <a:ext cx="2788920" cy="237744"/>
+          </a:xfrm>
+          <a:prstGeom prst="rect">
+            <a:avLst/>
+          </a:prstGeom>
+          <a:noFill/>
+        </p:spPr>
+        <p:txBody>
+          <a:bodyPr wrap="square" anchor="t" lIns="0" rIns="0" tIns="0" bIns="0">
+            <a:spAutoFit/>
+          </a:bodyPr>
+          <a:lstStyle/>
+          <a:p>
+            <a:pPr algn="l">
+              <a:lnSpc>
+                <a:spcPct val="118000"/>
+              </a:lnSpc>
+              <a:spcAft>
+                <a:spcPts val="0"/>
+              </a:spcAft>
+            </a:pPr>
+            <a:r>
+              <a:rPr sz="1050" b="0">
+                <a:solidFill>
+                  <a:srgbClr val="0F172A"/>
+                </a:solidFill>
+                <a:latin typeface="Inter"/>
+              </a:rPr>
+              <a:t>JBD SP24S007 V1.1</a:t>
+            </a:r>
+          </a:p>
+        </p:txBody>
+      </p:sp>
+      <p:sp>
+        <p:nvSpPr>
+          <p:cNvPr id="44" name="TextBox 43"/>
+          <p:cNvSpPr txBox="1"/>
+          <p:nvPr/>
+        </p:nvSpPr>
+        <p:spPr>
+          <a:xfrm>
+            <a:off x="9893808" y="3264407"/>
+            <a:ext cx="1529791" cy="219456"/>
+          </a:xfrm>
+          <a:prstGeom prst="rect">
+            <a:avLst/>
+          </a:prstGeom>
+          <a:noFill/>
+        </p:spPr>
+        <p:txBody>
+          <a:bodyPr wrap="square" anchor="t" lIns="0" rIns="0" tIns="0" bIns="0">
+            <a:spAutoFit/>
+          </a:bodyPr>
+          <a:lstStyle/>
+          <a:p>
+            <a:pPr algn="l">
+              <a:lnSpc>
+                <a:spcPct val="118000"/>
+              </a:lnSpc>
+              <a:spcAft>
+                <a:spcPts val="0"/>
+              </a:spcAft>
+            </a:pPr>
+            <a:r>
+              <a:rPr sz="900" b="0">
+                <a:solidFill>
+                  <a:srgbClr val="475569"/>
+                </a:solidFill>
+                <a:latin typeface="Inter"/>
+              </a:rPr>
+              <a:t>BMS protocol + registers</a:t>
+            </a:r>
+          </a:p>
+        </p:txBody>
+      </p:sp>
+      <p:sp>
+        <p:nvSpPr>
+          <p:cNvPr id="45" name="Rectangle 44"/>
+          <p:cNvSpPr/>
+          <p:nvPr/>
+        </p:nvSpPr>
+        <p:spPr>
+          <a:xfrm>
+            <a:off x="6693408" y="3730752"/>
+            <a:ext cx="4931359" cy="1883664"/>
+          </a:xfrm>
+          <a:prstGeom prst="rect">
+            <a:avLst/>
+          </a:prstGeom>
+          <a:solidFill>
+            <a:srgbClr val="F1F5F9"/>
+          </a:solidFill>
+          <a:ln w="9525">
+            <a:solidFill>
+              <a:srgbClr val="CBD5E1"/>
+            </a:solidFill>
+          </a:ln>
+          <a:effectLst/>
+        </p:spPr>
+        <p:style>
+          <a:lnRef idx="1">
+            <a:schemeClr val="accent1"/>
+          </a:lnRef>
+          <a:fillRef idx="3">
+            <a:schemeClr val="accent1"/>
+          </a:fillRef>
+          <a:effectRef idx="2">
+            <a:schemeClr val="accent1"/>
+          </a:effectRef>
+          <a:fontRef idx="minor">
+            <a:schemeClr val="lt1"/>
+          </a:fontRef>
+        </p:style>
+        <p:txBody>
+          <a:bodyPr rtlCol="0" anchor="ctr"/>
+          <a:lstStyle/>
+          <a:p/>
+        </p:txBody>
+      </p:sp>
+      <p:sp>
+        <p:nvSpPr>
+          <p:cNvPr id="46" name="TextBox 45"/>
+          <p:cNvSpPr txBox="1"/>
+          <p:nvPr/>
+        </p:nvSpPr>
+        <p:spPr>
+          <a:xfrm>
+            <a:off x="6894576" y="3858768"/>
+            <a:ext cx="4529023" cy="219456"/>
+          </a:xfrm>
+          <a:prstGeom prst="rect">
+            <a:avLst/>
+          </a:prstGeom>
+          <a:noFill/>
+        </p:spPr>
+        <p:txBody>
+          <a:bodyPr wrap="square" anchor="t" lIns="0" rIns="0" tIns="0" bIns="0">
+            <a:spAutoFit/>
+          </a:bodyPr>
+          <a:lstStyle/>
+          <a:p>
+            <a:pPr algn="l">
+              <a:lnSpc>
+                <a:spcPct val="118000"/>
+              </a:lnSpc>
+              <a:spcAft>
+                <a:spcPts val="0"/>
+              </a:spcAft>
+            </a:pPr>
+            <a:r>
+              <a:rPr sz="950" b="1">
+                <a:solidFill>
+                  <a:srgbClr val="B45309"/>
+                </a:solidFill>
+                <a:latin typeface="Inter"/>
+              </a:rPr>
+              <a:t>METHODS</a:t>
+            </a:r>
+          </a:p>
+        </p:txBody>
+      </p:sp>
+      <p:sp>
+        <p:nvSpPr>
+          <p:cNvPr id="47" name="TextBox 46"/>
+          <p:cNvSpPr txBox="1"/>
+          <p:nvPr/>
+        </p:nvSpPr>
+        <p:spPr>
+          <a:xfrm>
+            <a:off x="6912864" y="4151376"/>
+            <a:ext cx="4492447" cy="201168"/>
+          </a:xfrm>
+          <a:prstGeom prst="rect">
+            <a:avLst/>
+          </a:prstGeom>
+          <a:noFill/>
+        </p:spPr>
+        <p:txBody>
+          <a:bodyPr wrap="square" anchor="t" lIns="0" rIns="0" tIns="0" bIns="0">
+            <a:spAutoFit/>
+          </a:bodyPr>
+          <a:lstStyle/>
+          <a:p>
+            <a:pPr algn="l">
+              <a:lnSpc>
+                <a:spcPct val="118000"/>
+              </a:lnSpc>
+              <a:spcAft>
+                <a:spcPts val="0"/>
+              </a:spcAft>
+            </a:pPr>
+            <a:r>
+              <a:rPr sz="1050" b="1">
+                <a:solidFill>
+                  <a:srgbClr val="0F172A"/>
+                </a:solidFill>
+                <a:latin typeface="Inter"/>
+              </a:rPr>
+              <a:t>Chen, T. &amp; Guestrin, C.</a:t>
+            </a:r>
+          </a:p>
+        </p:txBody>
+      </p:sp>
+      <p:sp>
+        <p:nvSpPr>
+          <p:cNvPr id="48" name="TextBox 47"/>
+          <p:cNvSpPr txBox="1"/>
+          <p:nvPr/>
+        </p:nvSpPr>
+        <p:spPr>
+          <a:xfrm>
+            <a:off x="6912864" y="4325112"/>
+            <a:ext cx="4492447" cy="201168"/>
+          </a:xfrm>
+          <a:prstGeom prst="rect">
+            <a:avLst/>
+          </a:prstGeom>
+          <a:noFill/>
+        </p:spPr>
+        <p:txBody>
+          <a:bodyPr wrap="square" anchor="t" lIns="0" rIns="0" tIns="0" bIns="0">
+            <a:spAutoFit/>
+          </a:bodyPr>
+          <a:lstStyle/>
+          <a:p>
+            <a:pPr algn="l">
+              <a:lnSpc>
+                <a:spcPct val="118000"/>
+              </a:lnSpc>
+              <a:spcAft>
+                <a:spcPts val="0"/>
+              </a:spcAft>
+            </a:pPr>
+            <a:r>
+              <a:rPr sz="900" b="0">
+                <a:solidFill>
+                  <a:srgbClr val="475569"/>
+                </a:solidFill>
+                <a:latin typeface="Inter"/>
+              </a:rPr>
+              <a:t>“XGBoost: A Scalable Tree Boosting System”, KDD 2016</a:t>
+            </a:r>
+          </a:p>
+        </p:txBody>
+      </p:sp>
+      <p:sp>
+        <p:nvSpPr>
+          <p:cNvPr id="49" name="TextBox 48"/>
+          <p:cNvSpPr txBox="1"/>
+          <p:nvPr/>
+        </p:nvSpPr>
+        <p:spPr>
+          <a:xfrm>
+            <a:off x="6912864" y="4517136"/>
+            <a:ext cx="4492447" cy="201168"/>
+          </a:xfrm>
+          <a:prstGeom prst="rect">
+            <a:avLst/>
+          </a:prstGeom>
+          <a:noFill/>
+        </p:spPr>
+        <p:txBody>
+          <a:bodyPr wrap="square" anchor="t" lIns="0" rIns="0" tIns="0" bIns="0">
+            <a:spAutoFit/>
+          </a:bodyPr>
+          <a:lstStyle/>
+          <a:p>
+            <a:pPr algn="l">
+              <a:lnSpc>
+                <a:spcPct val="118000"/>
+              </a:lnSpc>
+              <a:spcAft>
+                <a:spcPts val="0"/>
+              </a:spcAft>
+            </a:pPr>
+            <a:r>
+              <a:rPr sz="1050" b="1">
+                <a:solidFill>
+                  <a:srgbClr val="0F172A"/>
+                </a:solidFill>
+                <a:latin typeface="Inter"/>
+              </a:rPr>
+              <a:t>Liu, F. T., Ting, K. M. &amp; Zhou, Z.-H.</a:t>
+            </a:r>
+          </a:p>
+        </p:txBody>
+      </p:sp>
+      <p:sp>
+        <p:nvSpPr>
+          <p:cNvPr id="50" name="TextBox 49"/>
+          <p:cNvSpPr txBox="1"/>
+          <p:nvPr/>
+        </p:nvSpPr>
+        <p:spPr>
+          <a:xfrm>
+            <a:off x="6912864" y="4690872"/>
+            <a:ext cx="4492447" cy="201168"/>
+          </a:xfrm>
+          <a:prstGeom prst="rect">
+            <a:avLst/>
+          </a:prstGeom>
+          <a:noFill/>
+        </p:spPr>
+        <p:txBody>
+          <a:bodyPr wrap="square" anchor="t" lIns="0" rIns="0" tIns="0" bIns="0">
+            <a:spAutoFit/>
+          </a:bodyPr>
+          <a:lstStyle/>
+          <a:p>
+            <a:pPr algn="l">
+              <a:lnSpc>
+                <a:spcPct val="118000"/>
+              </a:lnSpc>
+              <a:spcAft>
+                <a:spcPts val="0"/>
+              </a:spcAft>
+            </a:pPr>
+            <a:r>
+              <a:rPr sz="900" b="0">
+                <a:solidFill>
+                  <a:srgbClr val="475569"/>
+                </a:solidFill>
+                <a:latin typeface="Inter"/>
+              </a:rPr>
+              <a:t>“Isolation Forest”, ICDM 2008</a:t>
+            </a:r>
+          </a:p>
+        </p:txBody>
+      </p:sp>
+      <p:sp>
+        <p:nvSpPr>
+          <p:cNvPr id="51" name="TextBox 50"/>
+          <p:cNvSpPr txBox="1"/>
+          <p:nvPr/>
+        </p:nvSpPr>
+        <p:spPr>
+          <a:xfrm>
+            <a:off x="6912864" y="4882896"/>
+            <a:ext cx="4492447" cy="201168"/>
+          </a:xfrm>
+          <a:prstGeom prst="rect">
+            <a:avLst/>
+          </a:prstGeom>
+          <a:noFill/>
+        </p:spPr>
+        <p:txBody>
+          <a:bodyPr wrap="square" anchor="t" lIns="0" rIns="0" tIns="0" bIns="0">
+            <a:spAutoFit/>
+          </a:bodyPr>
+          <a:lstStyle/>
+          <a:p>
+            <a:pPr algn="l">
+              <a:lnSpc>
+                <a:spcPct val="118000"/>
+              </a:lnSpc>
+              <a:spcAft>
+                <a:spcPts val="0"/>
+              </a:spcAft>
+            </a:pPr>
+            <a:r>
+              <a:rPr sz="1050" b="1">
+                <a:solidFill>
+                  <a:srgbClr val="0F172A"/>
+                </a:solidFill>
+                <a:latin typeface="Inter"/>
+              </a:rPr>
+              <a:t>Vaswani, A. et al.</a:t>
+            </a:r>
+          </a:p>
+        </p:txBody>
+      </p:sp>
+      <p:sp>
+        <p:nvSpPr>
+          <p:cNvPr id="52" name="TextBox 51"/>
+          <p:cNvSpPr txBox="1"/>
+          <p:nvPr/>
+        </p:nvSpPr>
+        <p:spPr>
+          <a:xfrm>
+            <a:off x="6912864" y="5056632"/>
+            <a:ext cx="4492447" cy="201168"/>
+          </a:xfrm>
+          <a:prstGeom prst="rect">
+            <a:avLst/>
+          </a:prstGeom>
+          <a:noFill/>
+        </p:spPr>
+        <p:txBody>
+          <a:bodyPr wrap="square" anchor="t" lIns="0" rIns="0" tIns="0" bIns="0">
+            <a:spAutoFit/>
+          </a:bodyPr>
+          <a:lstStyle/>
+          <a:p>
+            <a:pPr algn="l">
+              <a:lnSpc>
+                <a:spcPct val="118000"/>
+              </a:lnSpc>
+              <a:spcAft>
+                <a:spcPts val="0"/>
+              </a:spcAft>
+            </a:pPr>
+            <a:r>
+              <a:rPr sz="900" b="0">
+                <a:solidFill>
+                  <a:srgbClr val="475569"/>
+                </a:solidFill>
+                <a:latin typeface="Inter"/>
+              </a:rPr>
+              <a:t>“Attention Is All You Need”, NeurIPS 2017</a:t>
+            </a:r>
+          </a:p>
+        </p:txBody>
+      </p:sp>
+      <p:sp>
+        <p:nvSpPr>
+          <p:cNvPr id="53" name="TextBox 52"/>
+          <p:cNvSpPr txBox="1"/>
+          <p:nvPr/>
+        </p:nvSpPr>
+        <p:spPr>
+          <a:xfrm>
+            <a:off x="6912864" y="5248656"/>
+            <a:ext cx="4492447" cy="201168"/>
+          </a:xfrm>
+          <a:prstGeom prst="rect">
+            <a:avLst/>
+          </a:prstGeom>
+          <a:noFill/>
+        </p:spPr>
+        <p:txBody>
+          <a:bodyPr wrap="square" anchor="t" lIns="0" rIns="0" tIns="0" bIns="0">
+            <a:spAutoFit/>
+          </a:bodyPr>
+          <a:lstStyle/>
+          <a:p>
+            <a:pPr algn="l">
+              <a:lnSpc>
+                <a:spcPct val="118000"/>
+              </a:lnSpc>
+              <a:spcAft>
+                <a:spcPts val="0"/>
+              </a:spcAft>
+            </a:pPr>
+            <a:r>
+              <a:rPr sz="1050" b="1">
+                <a:solidFill>
+                  <a:srgbClr val="0F172A"/>
+                </a:solidFill>
+                <a:latin typeface="Inter"/>
+              </a:rPr>
+              <a:t>Pedregosa, F. et al.</a:t>
+            </a:r>
+          </a:p>
+        </p:txBody>
+      </p:sp>
+      <p:sp>
+        <p:nvSpPr>
+          <p:cNvPr id="54" name="TextBox 53"/>
+          <p:cNvSpPr txBox="1"/>
+          <p:nvPr/>
+        </p:nvSpPr>
+        <p:spPr>
+          <a:xfrm>
+            <a:off x="6912864" y="5422392"/>
+            <a:ext cx="4492447" cy="201168"/>
+          </a:xfrm>
+          <a:prstGeom prst="rect">
+            <a:avLst/>
+          </a:prstGeom>
+          <a:noFill/>
+        </p:spPr>
+        <p:txBody>
+          <a:bodyPr wrap="square" anchor="t" lIns="0" rIns="0" tIns="0" bIns="0">
+            <a:spAutoFit/>
+          </a:bodyPr>
+          <a:lstStyle/>
+          <a:p>
+            <a:pPr algn="l">
+              <a:lnSpc>
+                <a:spcPct val="118000"/>
+              </a:lnSpc>
+              <a:spcAft>
+                <a:spcPts val="0"/>
+              </a:spcAft>
+            </a:pPr>
+            <a:r>
+              <a:rPr sz="900" b="0">
+                <a:solidFill>
+                  <a:srgbClr val="475569"/>
+                </a:solidFill>
+                <a:latin typeface="Inter"/>
+              </a:rPr>
+              <a:t>“Scikit-learn: Machine Learning in Python”, JMLR 12, 2011</a:t>
+            </a:r>
+          </a:p>
+        </p:txBody>
+      </p:sp>
+      <p:sp>
+        <p:nvSpPr>
+          <p:cNvPr id="55" name="TextBox 54"/>
+          <p:cNvSpPr txBox="1"/>
+          <p:nvPr/>
+        </p:nvSpPr>
+        <p:spPr>
+          <a:xfrm>
+            <a:off x="6693408" y="5760720"/>
+            <a:ext cx="4931359" cy="219456"/>
+          </a:xfrm>
+          <a:prstGeom prst="rect">
+            <a:avLst/>
+          </a:prstGeom>
+          <a:noFill/>
+        </p:spPr>
+        <p:txBody>
+          <a:bodyPr wrap="square" anchor="t" lIns="0" rIns="0" tIns="0" bIns="0">
+            <a:spAutoFit/>
+          </a:bodyPr>
+          <a:lstStyle/>
+          <a:p>
+            <a:pPr algn="l">
+              <a:lnSpc>
+                <a:spcPct val="118000"/>
+              </a:lnSpc>
+              <a:spcAft>
+                <a:spcPts val="0"/>
+              </a:spcAft>
+            </a:pPr>
+            <a:r>
+              <a:rPr sz="950" b="1">
+                <a:solidFill>
+                  <a:srgbClr val="475569"/>
+                </a:solidFill>
+                <a:latin typeface="Inter"/>
+              </a:rPr>
+              <a:t>STACK</a:t>
+            </a:r>
+          </a:p>
+        </p:txBody>
+      </p:sp>
+      <p:sp>
+        <p:nvSpPr>
+          <p:cNvPr id="56" name="TextBox 55"/>
+          <p:cNvSpPr txBox="1"/>
+          <p:nvPr/>
+        </p:nvSpPr>
+        <p:spPr>
+          <a:xfrm>
+            <a:off x="6693408" y="5998464"/>
+            <a:ext cx="4931359" cy="475488"/>
+          </a:xfrm>
+          <a:prstGeom prst="rect">
+            <a:avLst/>
+          </a:prstGeom>
+          <a:noFill/>
+        </p:spPr>
+        <p:txBody>
+          <a:bodyPr wrap="square" anchor="t" lIns="0" rIns="0" tIns="0" bIns="0">
+            <a:spAutoFit/>
+          </a:bodyPr>
+          <a:lstStyle/>
+          <a:p>
+            <a:pPr algn="l">
+              <a:lnSpc>
+                <a:spcPct val="132000"/>
+              </a:lnSpc>
+              <a:spcAft>
+                <a:spcPts val="0"/>
+              </a:spcAft>
+            </a:pPr>
+            <a:r>
+              <a:rPr sz="900" b="0">
+                <a:solidFill>
+                  <a:srgbClr val="475569"/>
+                </a:solidFill>
+                <a:latin typeface="Inter"/>
+              </a:rPr>
+              <a:t>xgboost 3.2.0  ·  scikit-learn 1.9.1  ·  torch 2.14.0  ·  numpy 2.4.6
+bleak  ·  Flask  ·  PostgreSQL  ·  Cloudflare Tunnel  ·  MATLAB / Simulink</a:t>
             </a:r>
           </a:p>
         </p:txBody>

</xml_diff>